<commit_message>
Add Spotlight product overview slide (slide 8)
Matches the MyInsights360 format: blue-bordered info box with title,
italic subtitle, and 3 bullets; device screenshot placeholder on the
left; and a 'What to Expect' section with bold-lead bullets on the right
covering anomaly detection, revenue recommendations, MI-360 integration,
and RFID expansion.

https://claude.ai/code/session_01LNdj45mY3WUBwsLnbkdguA
</commit_message>
<xml_diff>
--- a/OffsiteStores_Intelligence_updated.pptx
+++ b/OffsiteStores_Intelligence_updated.pptx
@@ -15,6 +15,7 @@
     <p:sldId id="288" r:id="rId6"/>
     <p:sldId id="289" r:id="rId12"/>
     <p:sldId id="290" r:id="rId13"/>
+    <p:sldId id="291" r:id="rId14"/>
   </p:sldIdLst>
   <p:sldSz cx="12192000" cy="6858000"/>
   <p:notesSz cx="6858000" cy="9144000"/>
@@ -11045,6 +11046,617 @@
                 </a:solidFill>
               </a:rPr>
               <a:t>32</a:t>
+            </a:r>
+          </a:p>
+        </p:txBody>
+      </p:sp>
+    </p:spTree>
+  </p:cSld>
+  <p:clrMapOvr>
+    <a:masterClrMapping/>
+  </p:clrMapOvr>
+</p:sld>
+</file>
+
+<file path=ppt/slides/slide8.xml><?xml version="1.0" encoding="utf-8"?>
+<p:sld xmlns:a="http://schemas.openxmlformats.org/drawingml/2006/main" xmlns:p="http://schemas.openxmlformats.org/presentationml/2006/main" xmlns:r="http://schemas.openxmlformats.org/officeDocument/2006/relationships">
+  <p:cSld>
+    <p:bg>
+      <p:bgPr>
+        <a:solidFill>
+          <a:srgbClr val="FFFFFF"/>
+        </a:solidFill>
+        <a:effectLst/>
+      </p:bgPr>
+    </p:bg>
+    <p:spTree>
+      <p:nvGrpSpPr>
+        <p:cNvPr id="1" name=""/>
+        <p:cNvGrpSpPr/>
+        <p:nvPr/>
+      </p:nvGrpSpPr>
+      <p:grpSpPr/>
+      <p:sp>
+        <p:nvSpPr>
+          <p:cNvPr id="2" name="Rectangle 1"/>
+          <p:cNvSpPr/>
+          <p:nvPr/>
+        </p:nvSpPr>
+        <p:spPr>
+          <a:xfrm>
+            <a:off x="347472" y="292608"/>
+            <a:ext cx="4023360" cy="2423160"/>
+          </a:xfrm>
+          <a:prstGeom prst="rect">
+            <a:avLst/>
+          </a:prstGeom>
+          <a:solidFill>
+            <a:srgbClr val="FFFFFF"/>
+          </a:solidFill>
+          <a:ln w="25400">
+            <a:solidFill>
+              <a:srgbClr val="1E6FC8"/>
+            </a:solidFill>
+          </a:ln>
+        </p:spPr>
+        <p:style>
+          <a:lnRef idx="1">
+            <a:schemeClr val="accent1"/>
+          </a:lnRef>
+          <a:fillRef idx="3">
+            <a:schemeClr val="accent1"/>
+          </a:fillRef>
+          <a:effectRef idx="2">
+            <a:schemeClr val="accent1"/>
+          </a:effectRef>
+          <a:fontRef idx="minor">
+            <a:schemeClr val="lt1"/>
+          </a:fontRef>
+        </p:style>
+        <p:txBody>
+          <a:bodyPr rtlCol="0" anchor="ctr"/>
+          <a:lstStyle/>
+          <a:p>
+            <a:pPr algn="ctr"/>
+          </a:p>
+        </p:txBody>
+      </p:sp>
+      <p:sp>
+        <p:nvSpPr>
+          <p:cNvPr id="3" name="TextBox 2"/>
+          <p:cNvSpPr txBox="1"/>
+          <p:nvPr/>
+        </p:nvSpPr>
+        <p:spPr>
+          <a:xfrm>
+            <a:off x="530352" y="384048"/>
+            <a:ext cx="3657600" cy="384048"/>
+          </a:xfrm>
+          <a:prstGeom prst="rect">
+            <a:avLst/>
+          </a:prstGeom>
+          <a:noFill/>
+        </p:spPr>
+        <p:txBody>
+          <a:bodyPr wrap="square">
+            <a:spAutoFit/>
+          </a:bodyPr>
+          <a:lstStyle/>
+          <a:p>
+            <a:r>
+              <a:rPr sz="1900" b="1" i="0">
+                <a:solidFill>
+                  <a:srgbClr val="222222"/>
+                </a:solidFill>
+              </a:rPr>
+              <a:t>Spotlight</a:t>
+            </a:r>
+          </a:p>
+        </p:txBody>
+      </p:sp>
+      <p:sp>
+        <p:nvSpPr>
+          <p:cNvPr id="4" name="TextBox 3"/>
+          <p:cNvSpPr txBox="1"/>
+          <p:nvPr/>
+        </p:nvSpPr>
+        <p:spPr>
+          <a:xfrm>
+            <a:off x="530352" y="786384"/>
+            <a:ext cx="3657600" cy="292608"/>
+          </a:xfrm>
+          <a:prstGeom prst="rect">
+            <a:avLst/>
+          </a:prstGeom>
+          <a:noFill/>
+        </p:spPr>
+        <p:txBody>
+          <a:bodyPr wrap="square">
+            <a:spAutoFit/>
+          </a:bodyPr>
+          <a:lstStyle/>
+          <a:p>
+            <a:r>
+              <a:rPr sz="1200" b="0" i="1">
+                <a:solidFill>
+                  <a:srgbClr val="1E6FC8"/>
+                </a:solidFill>
+              </a:rPr>
+              <a:t>Stores AI Platform</a:t>
+            </a:r>
+          </a:p>
+        </p:txBody>
+      </p:sp>
+      <p:sp>
+        <p:nvSpPr>
+          <p:cNvPr id="5" name="TextBox 4"/>
+          <p:cNvSpPr txBox="1"/>
+          <p:nvPr/>
+        </p:nvSpPr>
+        <p:spPr>
+          <a:xfrm>
+            <a:off x="530352" y="1188720"/>
+            <a:ext cx="3749039" cy="411480"/>
+          </a:xfrm>
+          <a:prstGeom prst="rect">
+            <a:avLst/>
+          </a:prstGeom>
+          <a:noFill/>
+        </p:spPr>
+        <p:txBody>
+          <a:bodyPr wrap="square">
+            <a:spAutoFit/>
+          </a:bodyPr>
+          <a:lstStyle/>
+          <a:p>
+            <a:r>
+              <a:rPr sz="1000" b="0" i="0">
+                <a:solidFill>
+                  <a:srgbClr val="1E6FC8"/>
+                </a:solidFill>
+              </a:rPr>
+              <a:t>• </a:t>
+            </a:r>
+            <a:r>
+              <a:rPr sz="1000" b="0" i="0">
+                <a:solidFill>
+                  <a:srgbClr val="444444"/>
+                </a:solidFill>
+              </a:rPr>
+              <a:t>AI-powered anomaly detection for store associates</a:t>
+            </a:r>
+          </a:p>
+        </p:txBody>
+      </p:sp>
+      <p:sp>
+        <p:nvSpPr>
+          <p:cNvPr id="6" name="TextBox 5"/>
+          <p:cNvSpPr txBox="1"/>
+          <p:nvPr/>
+        </p:nvSpPr>
+        <p:spPr>
+          <a:xfrm>
+            <a:off x="530352" y="1645920"/>
+            <a:ext cx="3749039" cy="411480"/>
+          </a:xfrm>
+          <a:prstGeom prst="rect">
+            <a:avLst/>
+          </a:prstGeom>
+          <a:noFill/>
+        </p:spPr>
+        <p:txBody>
+          <a:bodyPr wrap="square">
+            <a:spAutoFit/>
+          </a:bodyPr>
+          <a:lstStyle/>
+          <a:p>
+            <a:r>
+              <a:rPr sz="1000" b="0" i="0">
+                <a:solidFill>
+                  <a:srgbClr val="1E6FC8"/>
+                </a:solidFill>
+              </a:rPr>
+              <a:t>• </a:t>
+            </a:r>
+            <a:r>
+              <a:rPr sz="1000" b="0" i="0">
+                <a:solidFill>
+                  <a:srgbClr val="444444"/>
+                </a:solidFill>
+              </a:rPr>
+              <a:t>Revenue opportunity identification at the store level</a:t>
+            </a:r>
+          </a:p>
+        </p:txBody>
+      </p:sp>
+      <p:sp>
+        <p:nvSpPr>
+          <p:cNvPr id="7" name="TextBox 6"/>
+          <p:cNvSpPr txBox="1"/>
+          <p:nvPr/>
+        </p:nvSpPr>
+        <p:spPr>
+          <a:xfrm>
+            <a:off x="530352" y="2103120"/>
+            <a:ext cx="3749039" cy="411480"/>
+          </a:xfrm>
+          <a:prstGeom prst="rect">
+            <a:avLst/>
+          </a:prstGeom>
+          <a:noFill/>
+        </p:spPr>
+        <p:txBody>
+          <a:bodyPr wrap="square">
+            <a:spAutoFit/>
+          </a:bodyPr>
+          <a:lstStyle/>
+          <a:p>
+            <a:r>
+              <a:rPr sz="1000" b="0" i="0">
+                <a:solidFill>
+                  <a:srgbClr val="1E6FC8"/>
+                </a:solidFill>
+              </a:rPr>
+              <a:t>• </a:t>
+            </a:r>
+            <a:r>
+              <a:rPr sz="1000" b="0" i="0">
+                <a:solidFill>
+                  <a:srgbClr val="444444"/>
+                </a:solidFill>
+              </a:rPr>
+              <a:t>Live across 85% of GAP's store fleet (excl. GAP Japan)</a:t>
+            </a:r>
+          </a:p>
+        </p:txBody>
+      </p:sp>
+      <p:sp>
+        <p:nvSpPr>
+          <p:cNvPr id="8" name="Rectangle 7"/>
+          <p:cNvSpPr/>
+          <p:nvPr/>
+        </p:nvSpPr>
+        <p:spPr>
+          <a:xfrm>
+            <a:off x="292608" y="2907792"/>
+            <a:ext cx="3246120" cy="3703320"/>
+          </a:xfrm>
+          <a:prstGeom prst="rect">
+            <a:avLst/>
+          </a:prstGeom>
+          <a:solidFill>
+            <a:srgbClr val="F0F4F8"/>
+          </a:solidFill>
+          <a:ln w="12700">
+            <a:solidFill>
+              <a:srgbClr val="CCCCCC"/>
+            </a:solidFill>
+          </a:ln>
+        </p:spPr>
+        <p:style>
+          <a:lnRef idx="1">
+            <a:schemeClr val="accent1"/>
+          </a:lnRef>
+          <a:fillRef idx="3">
+            <a:schemeClr val="accent1"/>
+          </a:fillRef>
+          <a:effectRef idx="2">
+            <a:schemeClr val="accent1"/>
+          </a:effectRef>
+          <a:fontRef idx="minor">
+            <a:schemeClr val="lt1"/>
+          </a:fontRef>
+        </p:style>
+        <p:txBody>
+          <a:bodyPr rtlCol="0" anchor="ctr"/>
+          <a:lstStyle/>
+          <a:p>
+            <a:pPr algn="ctr"/>
+          </a:p>
+        </p:txBody>
+      </p:sp>
+      <p:sp>
+        <p:nvSpPr>
+          <p:cNvPr id="9" name="TextBox 8"/>
+          <p:cNvSpPr txBox="1"/>
+          <p:nvPr/>
+        </p:nvSpPr>
+        <p:spPr>
+          <a:xfrm>
+            <a:off x="475488" y="4617720"/>
+            <a:ext cx="2880360" cy="502920"/>
+          </a:xfrm>
+          <a:prstGeom prst="rect">
+            <a:avLst/>
+          </a:prstGeom>
+          <a:noFill/>
+        </p:spPr>
+        <p:txBody>
+          <a:bodyPr wrap="square">
+            <a:spAutoFit/>
+          </a:bodyPr>
+          <a:lstStyle/>
+          <a:p>
+            <a:r>
+              <a:rPr sz="900" b="0" i="1">
+                <a:solidFill>
+                  <a:srgbClr val="CCCCCC"/>
+                </a:solidFill>
+              </a:rPr>
+              <a:t>[ Insert Spotlight
+app screenshot ]</a:t>
+            </a:r>
+          </a:p>
+        </p:txBody>
+      </p:sp>
+      <p:sp>
+        <p:nvSpPr>
+          <p:cNvPr id="10" name="TextBox 9"/>
+          <p:cNvSpPr txBox="1"/>
+          <p:nvPr/>
+        </p:nvSpPr>
+        <p:spPr>
+          <a:xfrm>
+            <a:off x="3840480" y="2834640"/>
+            <a:ext cx="8092440" cy="457200"/>
+          </a:xfrm>
+          <a:prstGeom prst="rect">
+            <a:avLst/>
+          </a:prstGeom>
+          <a:noFill/>
+        </p:spPr>
+        <p:txBody>
+          <a:bodyPr wrap="square">
+            <a:spAutoFit/>
+          </a:bodyPr>
+          <a:lstStyle/>
+          <a:p>
+            <a:r>
+              <a:rPr sz="1600" b="1" i="0">
+                <a:solidFill>
+                  <a:srgbClr val="222222"/>
+                </a:solidFill>
+              </a:rPr>
+              <a:t>What to Expect</a:t>
+            </a:r>
+          </a:p>
+        </p:txBody>
+      </p:sp>
+      <p:sp>
+        <p:nvSpPr>
+          <p:cNvPr id="11" name="Rectangle 10"/>
+          <p:cNvSpPr/>
+          <p:nvPr/>
+        </p:nvSpPr>
+        <p:spPr>
+          <a:xfrm>
+            <a:off x="3840480" y="3310128"/>
+            <a:ext cx="8092440" cy="27432"/>
+          </a:xfrm>
+          <a:prstGeom prst="rect">
+            <a:avLst/>
+          </a:prstGeom>
+          <a:solidFill>
+            <a:srgbClr val="CCCCCC"/>
+          </a:solidFill>
+          <a:ln>
+            <a:noFill/>
+          </a:ln>
+        </p:spPr>
+        <p:style>
+          <a:lnRef idx="1">
+            <a:schemeClr val="accent1"/>
+          </a:lnRef>
+          <a:fillRef idx="3">
+            <a:schemeClr val="accent1"/>
+          </a:fillRef>
+          <a:effectRef idx="2">
+            <a:schemeClr val="accent1"/>
+          </a:effectRef>
+          <a:fontRef idx="minor">
+            <a:schemeClr val="lt1"/>
+          </a:fontRef>
+        </p:style>
+        <p:txBody>
+          <a:bodyPr rtlCol="0" anchor="ctr"/>
+          <a:lstStyle/>
+          <a:p>
+            <a:pPr algn="ctr"/>
+          </a:p>
+        </p:txBody>
+      </p:sp>
+      <p:sp>
+        <p:nvSpPr>
+          <p:cNvPr id="12" name="TextBox 11"/>
+          <p:cNvSpPr txBox="1"/>
+          <p:nvPr/>
+        </p:nvSpPr>
+        <p:spPr>
+          <a:xfrm>
+            <a:off x="3840480" y="3456432"/>
+            <a:ext cx="8092440" cy="749808"/>
+          </a:xfrm>
+          <a:prstGeom prst="rect">
+            <a:avLst/>
+          </a:prstGeom>
+          <a:noFill/>
+        </p:spPr>
+        <p:txBody>
+          <a:bodyPr wrap="square">
+            <a:spAutoFit/>
+          </a:bodyPr>
+          <a:lstStyle/>
+          <a:p>
+            <a:r>
+              <a:rPr sz="1100" b="0">
+                <a:solidFill>
+                  <a:srgbClr val="1E6FC8"/>
+                </a:solidFill>
+              </a:rPr>
+              <a:t>•  </a:t>
+            </a:r>
+            <a:r>
+              <a:rPr sz="1100" b="1">
+                <a:solidFill>
+                  <a:srgbClr val="222222"/>
+                </a:solidFill>
+              </a:rPr>
+              <a:t>Anomaly detection at scale, </a:t>
+            </a:r>
+            <a:r>
+              <a:rPr sz="1100" b="0">
+                <a:solidFill>
+                  <a:srgbClr val="444444"/>
+                </a:solidFill>
+              </a:rPr>
+              <a:t>surfacing issues store associates can act on before they impact revenue.</a:t>
+            </a:r>
+          </a:p>
+        </p:txBody>
+      </p:sp>
+      <p:sp>
+        <p:nvSpPr>
+          <p:cNvPr id="13" name="TextBox 12"/>
+          <p:cNvSpPr txBox="1"/>
+          <p:nvPr/>
+        </p:nvSpPr>
+        <p:spPr>
+          <a:xfrm>
+            <a:off x="3840480" y="4261104"/>
+            <a:ext cx="8092440" cy="749808"/>
+          </a:xfrm>
+          <a:prstGeom prst="rect">
+            <a:avLst/>
+          </a:prstGeom>
+          <a:noFill/>
+        </p:spPr>
+        <p:txBody>
+          <a:bodyPr wrap="square">
+            <a:spAutoFit/>
+          </a:bodyPr>
+          <a:lstStyle/>
+          <a:p>
+            <a:r>
+              <a:rPr sz="1100" b="0">
+                <a:solidFill>
+                  <a:srgbClr val="1E6FC8"/>
+                </a:solidFill>
+              </a:rPr>
+              <a:t>•  </a:t>
+            </a:r>
+            <a:r>
+              <a:rPr sz="1100" b="1">
+                <a:solidFill>
+                  <a:srgbClr val="222222"/>
+                </a:solidFill>
+              </a:rPr>
+              <a:t>Revenue recommendations, </a:t>
+            </a:r>
+            <a:r>
+              <a:rPr sz="1100" b="0">
+                <a:solidFill>
+                  <a:srgbClr val="444444"/>
+                </a:solidFill>
+              </a:rPr>
+              <a:t>identifying missed opportunities specific to each store's unique traffic and sales patterns.</a:t>
+            </a:r>
+          </a:p>
+        </p:txBody>
+      </p:sp>
+      <p:sp>
+        <p:nvSpPr>
+          <p:cNvPr id="14" name="TextBox 13"/>
+          <p:cNvSpPr txBox="1"/>
+          <p:nvPr/>
+        </p:nvSpPr>
+        <p:spPr>
+          <a:xfrm>
+            <a:off x="3840480" y="5065776"/>
+            <a:ext cx="8092440" cy="749808"/>
+          </a:xfrm>
+          <a:prstGeom prst="rect">
+            <a:avLst/>
+          </a:prstGeom>
+          <a:noFill/>
+        </p:spPr>
+        <p:txBody>
+          <a:bodyPr wrap="square">
+            <a:spAutoFit/>
+          </a:bodyPr>
+          <a:lstStyle/>
+          <a:p>
+            <a:r>
+              <a:rPr sz="1100" b="0">
+                <a:solidFill>
+                  <a:srgbClr val="1E6FC8"/>
+                </a:solidFill>
+              </a:rPr>
+              <a:t>•  </a:t>
+            </a:r>
+            <a:r>
+              <a:rPr sz="1100" b="1">
+                <a:solidFill>
+                  <a:srgbClr val="222222"/>
+                </a:solidFill>
+              </a:rPr>
+              <a:t>Seamless integration with MI-360, </a:t>
+            </a:r>
+            <a:r>
+              <a:rPr sz="1100" b="0">
+                <a:solidFill>
+                  <a:srgbClr val="444444"/>
+                </a:solidFill>
+              </a:rPr>
+              <a:t>bringing AI-generated insights into the same platform store leaders already use daily.</a:t>
+            </a:r>
+          </a:p>
+        </p:txBody>
+      </p:sp>
+      <p:sp>
+        <p:nvSpPr>
+          <p:cNvPr id="15" name="TextBox 14"/>
+          <p:cNvSpPr txBox="1"/>
+          <p:nvPr/>
+        </p:nvSpPr>
+        <p:spPr>
+          <a:xfrm>
+            <a:off x="3840480" y="5870448"/>
+            <a:ext cx="8092440" cy="749808"/>
+          </a:xfrm>
+          <a:prstGeom prst="rect">
+            <a:avLst/>
+          </a:prstGeom>
+          <a:noFill/>
+        </p:spPr>
+        <p:txBody>
+          <a:bodyPr wrap="square">
+            <a:spAutoFit/>
+          </a:bodyPr>
+          <a:lstStyle/>
+          <a:p>
+            <a:r>
+              <a:rPr sz="1100" b="0">
+                <a:solidFill>
+                  <a:srgbClr val="1E6FC8"/>
+                </a:solidFill>
+              </a:rPr>
+              <a:t>•  </a:t>
+            </a:r>
+            <a:r>
+              <a:rPr sz="1100" b="1">
+                <a:solidFill>
+                  <a:srgbClr val="222222"/>
+                </a:solidFill>
+              </a:rPr>
+              <a:t>RFID expansion in FY27, </a:t>
+            </a:r>
+            <a:r>
+              <a:rPr sz="1100" b="0">
+                <a:solidFill>
+                  <a:srgbClr val="444444"/>
+                </a:solidFill>
+              </a:rPr>
+              <a:t>extending inventory intelligence across all North America brands — starting from Old Navy.</a:t>
             </a:r>
           </a:p>
         </p:txBody>

</xml_diff>

<commit_message>
Add AI Chatbot use cases slide (slide 9)
Three-card layout covering Sales Performance Q&A, Product Intelligence,
and Location & Store use cases, with natural language query bubbles
styled to suggest a conversational interface.

https://claude.ai/code/session_01LNdj45mY3WUBwsLnbkdguA
</commit_message>
<xml_diff>
--- a/OffsiteStores_Intelligence_updated.pptx
+++ b/OffsiteStores_Intelligence_updated.pptx
@@ -16,6 +16,7 @@
     <p:sldId id="289" r:id="rId12"/>
     <p:sldId id="290" r:id="rId13"/>
     <p:sldId id="291" r:id="rId14"/>
+    <p:sldId id="292" r:id="rId15"/>
   </p:sldIdLst>
   <p:sldSz cx="12192000" cy="6858000"/>
   <p:notesSz cx="6858000" cy="9144000"/>
@@ -11657,6 +11658,1230 @@
                 </a:solidFill>
               </a:rPr>
               <a:t>extending inventory intelligence across all North America brands — starting from Old Navy.</a:t>
+            </a:r>
+          </a:p>
+        </p:txBody>
+      </p:sp>
+    </p:spTree>
+  </p:cSld>
+  <p:clrMapOvr>
+    <a:masterClrMapping/>
+  </p:clrMapOvr>
+</p:sld>
+</file>
+
+<file path=ppt/slides/slide9.xml><?xml version="1.0" encoding="utf-8"?>
+<p:sld xmlns:a="http://schemas.openxmlformats.org/drawingml/2006/main" xmlns:p="http://schemas.openxmlformats.org/presentationml/2006/main" xmlns:r="http://schemas.openxmlformats.org/officeDocument/2006/relationships">
+  <p:cSld>
+    <p:bg>
+      <p:bgPr>
+        <a:solidFill>
+          <a:srgbClr val="FFFFFF"/>
+        </a:solidFill>
+        <a:effectLst/>
+      </p:bgPr>
+    </p:bg>
+    <p:spTree>
+      <p:nvGrpSpPr>
+        <p:cNvPr id="1" name=""/>
+        <p:cNvGrpSpPr/>
+        <p:nvPr/>
+      </p:nvGrpSpPr>
+      <p:grpSpPr/>
+      <p:sp>
+        <p:nvSpPr>
+          <p:cNvPr id="2" name="TextBox 1"/>
+          <p:cNvSpPr txBox="1"/>
+          <p:nvPr/>
+        </p:nvSpPr>
+        <p:spPr>
+          <a:xfrm>
+            <a:off x="365760" y="246888"/>
+            <a:ext cx="11457432" cy="502920"/>
+          </a:xfrm>
+          <a:prstGeom prst="rect">
+            <a:avLst/>
+          </a:prstGeom>
+          <a:noFill/>
+        </p:spPr>
+        <p:txBody>
+          <a:bodyPr wrap="square">
+            <a:spAutoFit/>
+          </a:bodyPr>
+          <a:lstStyle/>
+          <a:p>
+            <a:pPr algn="l"/>
+            <a:r>
+              <a:rPr sz="3200" b="1" i="0">
+                <a:solidFill>
+                  <a:srgbClr val="111827"/>
+                </a:solidFill>
+              </a:rPr>
+              <a:t>AI Chatbot — Use Cases</a:t>
+            </a:r>
+          </a:p>
+        </p:txBody>
+      </p:sp>
+      <p:sp>
+        <p:nvSpPr>
+          <p:cNvPr id="3" name="TextBox 2"/>
+          <p:cNvSpPr txBox="1"/>
+          <p:nvPr/>
+        </p:nvSpPr>
+        <p:spPr>
+          <a:xfrm>
+            <a:off x="365760" y="795528"/>
+            <a:ext cx="11457432" cy="347472"/>
+          </a:xfrm>
+          <a:prstGeom prst="rect">
+            <a:avLst/>
+          </a:prstGeom>
+          <a:noFill/>
+        </p:spPr>
+        <p:txBody>
+          <a:bodyPr wrap="square">
+            <a:spAutoFit/>
+          </a:bodyPr>
+          <a:lstStyle/>
+          <a:p>
+            <a:pPr algn="l"/>
+            <a:r>
+              <a:rPr sz="1500" b="0" i="0">
+                <a:solidFill>
+                  <a:srgbClr val="6B7280"/>
+                </a:solidFill>
+              </a:rPr>
+              <a:t>Natural language queries store leaders and associates can ask — no filters, no training required</a:t>
+            </a:r>
+          </a:p>
+        </p:txBody>
+      </p:sp>
+      <p:sp>
+        <p:nvSpPr>
+          <p:cNvPr id="4" name="Rectangle 3"/>
+          <p:cNvSpPr/>
+          <p:nvPr/>
+        </p:nvSpPr>
+        <p:spPr>
+          <a:xfrm>
+            <a:off x="365760" y="1298448"/>
+            <a:ext cx="3694176" cy="5349240"/>
+          </a:xfrm>
+          <a:prstGeom prst="rect">
+            <a:avLst/>
+          </a:prstGeom>
+          <a:solidFill>
+            <a:srgbClr val="F9FAFB"/>
+          </a:solidFill>
+          <a:ln>
+            <a:noFill/>
+          </a:ln>
+        </p:spPr>
+        <p:style>
+          <a:lnRef idx="1">
+            <a:schemeClr val="accent1"/>
+          </a:lnRef>
+          <a:fillRef idx="3">
+            <a:schemeClr val="accent1"/>
+          </a:fillRef>
+          <a:effectRef idx="2">
+            <a:schemeClr val="accent1"/>
+          </a:effectRef>
+          <a:fontRef idx="minor">
+            <a:schemeClr val="lt1"/>
+          </a:fontRef>
+        </p:style>
+        <p:txBody>
+          <a:bodyPr rtlCol="0" anchor="ctr"/>
+          <a:lstStyle/>
+          <a:p>
+            <a:pPr algn="ctr"/>
+          </a:p>
+        </p:txBody>
+      </p:sp>
+      <p:sp>
+        <p:nvSpPr>
+          <p:cNvPr id="5" name="Rectangle 4"/>
+          <p:cNvSpPr/>
+          <p:nvPr/>
+        </p:nvSpPr>
+        <p:spPr>
+          <a:xfrm>
+            <a:off x="365760" y="1298448"/>
+            <a:ext cx="3694176" cy="91440"/>
+          </a:xfrm>
+          <a:prstGeom prst="rect">
+            <a:avLst/>
+          </a:prstGeom>
+          <a:solidFill>
+            <a:srgbClr val="1976D2"/>
+          </a:solidFill>
+          <a:ln>
+            <a:noFill/>
+          </a:ln>
+        </p:spPr>
+        <p:style>
+          <a:lnRef idx="1">
+            <a:schemeClr val="accent1"/>
+          </a:lnRef>
+          <a:fillRef idx="3">
+            <a:schemeClr val="accent1"/>
+          </a:fillRef>
+          <a:effectRef idx="2">
+            <a:schemeClr val="accent1"/>
+          </a:effectRef>
+          <a:fontRef idx="minor">
+            <a:schemeClr val="lt1"/>
+          </a:fontRef>
+        </p:style>
+        <p:txBody>
+          <a:bodyPr rtlCol="0" anchor="ctr"/>
+          <a:lstStyle/>
+          <a:p>
+            <a:pPr algn="ctr"/>
+          </a:p>
+        </p:txBody>
+      </p:sp>
+      <p:sp>
+        <p:nvSpPr>
+          <p:cNvPr id="6" name="TextBox 5"/>
+          <p:cNvSpPr txBox="1"/>
+          <p:nvPr/>
+        </p:nvSpPr>
+        <p:spPr>
+          <a:xfrm>
+            <a:off x="530352" y="1453895"/>
+            <a:ext cx="3419856" cy="320040"/>
+          </a:xfrm>
+          <a:prstGeom prst="rect">
+            <a:avLst/>
+          </a:prstGeom>
+          <a:noFill/>
+        </p:spPr>
+        <p:txBody>
+          <a:bodyPr wrap="square">
+            <a:spAutoFit/>
+          </a:bodyPr>
+          <a:lstStyle/>
+          <a:p>
+            <a:pPr algn="l"/>
+            <a:r>
+              <a:rPr sz="950" b="1" i="0">
+                <a:solidFill>
+                  <a:srgbClr val="1976D2"/>
+                </a:solidFill>
+              </a:rPr>
+              <a:t>USE CASE 1</a:t>
+            </a:r>
+          </a:p>
+        </p:txBody>
+      </p:sp>
+      <p:sp>
+        <p:nvSpPr>
+          <p:cNvPr id="7" name="TextBox 6"/>
+          <p:cNvSpPr txBox="1"/>
+          <p:nvPr/>
+        </p:nvSpPr>
+        <p:spPr>
+          <a:xfrm>
+            <a:off x="530352" y="1773936"/>
+            <a:ext cx="3419856" cy="566928"/>
+          </a:xfrm>
+          <a:prstGeom prst="rect">
+            <a:avLst/>
+          </a:prstGeom>
+          <a:noFill/>
+        </p:spPr>
+        <p:txBody>
+          <a:bodyPr wrap="square">
+            <a:spAutoFit/>
+          </a:bodyPr>
+          <a:lstStyle/>
+          <a:p>
+            <a:pPr algn="l"/>
+            <a:r>
+              <a:rPr sz="1700" b="1" i="0">
+                <a:solidFill>
+                  <a:srgbClr val="111827"/>
+                </a:solidFill>
+              </a:rPr>
+              <a:t>Sales Performance Q&amp;A</a:t>
+            </a:r>
+          </a:p>
+        </p:txBody>
+      </p:sp>
+      <p:sp>
+        <p:nvSpPr>
+          <p:cNvPr id="8" name="Rectangle 7"/>
+          <p:cNvSpPr/>
+          <p:nvPr/>
+        </p:nvSpPr>
+        <p:spPr>
+          <a:xfrm>
+            <a:off x="530352" y="2377439"/>
+            <a:ext cx="3364992" cy="16459"/>
+          </a:xfrm>
+          <a:prstGeom prst="rect">
+            <a:avLst/>
+          </a:prstGeom>
+          <a:solidFill>
+            <a:srgbClr val="C4C9D4"/>
+          </a:solidFill>
+          <a:ln>
+            <a:noFill/>
+          </a:ln>
+        </p:spPr>
+        <p:style>
+          <a:lnRef idx="1">
+            <a:schemeClr val="accent1"/>
+          </a:lnRef>
+          <a:fillRef idx="3">
+            <a:schemeClr val="accent1"/>
+          </a:fillRef>
+          <a:effectRef idx="2">
+            <a:schemeClr val="accent1"/>
+          </a:effectRef>
+          <a:fontRef idx="minor">
+            <a:schemeClr val="lt1"/>
+          </a:fontRef>
+        </p:style>
+        <p:txBody>
+          <a:bodyPr rtlCol="0" anchor="ctr"/>
+          <a:lstStyle/>
+          <a:p>
+            <a:pPr algn="ctr"/>
+          </a:p>
+        </p:txBody>
+      </p:sp>
+      <p:sp>
+        <p:nvSpPr>
+          <p:cNvPr id="9" name="Rectangle 8"/>
+          <p:cNvSpPr/>
+          <p:nvPr/>
+        </p:nvSpPr>
+        <p:spPr>
+          <a:xfrm>
+            <a:off x="530352" y="2487168"/>
+            <a:ext cx="3364992" cy="932688"/>
+          </a:xfrm>
+          <a:prstGeom prst="rect">
+            <a:avLst/>
+          </a:prstGeom>
+          <a:solidFill>
+            <a:srgbClr val="EBF3FF"/>
+          </a:solidFill>
+          <a:ln>
+            <a:noFill/>
+          </a:ln>
+        </p:spPr>
+        <p:style>
+          <a:lnRef idx="1">
+            <a:schemeClr val="accent1"/>
+          </a:lnRef>
+          <a:fillRef idx="3">
+            <a:schemeClr val="accent1"/>
+          </a:fillRef>
+          <a:effectRef idx="2">
+            <a:schemeClr val="accent1"/>
+          </a:effectRef>
+          <a:fontRef idx="minor">
+            <a:schemeClr val="lt1"/>
+          </a:fontRef>
+        </p:style>
+        <p:txBody>
+          <a:bodyPr rtlCol="0" anchor="ctr"/>
+          <a:lstStyle/>
+          <a:p>
+            <a:pPr algn="ctr"/>
+          </a:p>
+        </p:txBody>
+      </p:sp>
+      <p:sp>
+        <p:nvSpPr>
+          <p:cNvPr id="10" name="TextBox 9"/>
+          <p:cNvSpPr txBox="1"/>
+          <p:nvPr/>
+        </p:nvSpPr>
+        <p:spPr>
+          <a:xfrm>
+            <a:off x="621792" y="2578608"/>
+            <a:ext cx="3182112" cy="822960"/>
+          </a:xfrm>
+          <a:prstGeom prst="rect">
+            <a:avLst/>
+          </a:prstGeom>
+          <a:noFill/>
+        </p:spPr>
+        <p:txBody>
+          <a:bodyPr wrap="square">
+            <a:spAutoFit/>
+          </a:bodyPr>
+          <a:lstStyle/>
+          <a:p>
+            <a:pPr algn="l"/>
+            <a:r>
+              <a:rPr sz="1050" b="0" i="1">
+                <a:solidFill>
+                  <a:srgbClr val="1E3A6E"/>
+                </a:solidFill>
+              </a:rPr>
+              <a:t>"What were Old Navy's top-selling categories last quarter?"</a:t>
+            </a:r>
+          </a:p>
+        </p:txBody>
+      </p:sp>
+      <p:sp>
+        <p:nvSpPr>
+          <p:cNvPr id="11" name="Rectangle 10"/>
+          <p:cNvSpPr/>
+          <p:nvPr/>
+        </p:nvSpPr>
+        <p:spPr>
+          <a:xfrm>
+            <a:off x="530352" y="3538727"/>
+            <a:ext cx="3364992" cy="932688"/>
+          </a:xfrm>
+          <a:prstGeom prst="rect">
+            <a:avLst/>
+          </a:prstGeom>
+          <a:solidFill>
+            <a:srgbClr val="EBF3FF"/>
+          </a:solidFill>
+          <a:ln>
+            <a:noFill/>
+          </a:ln>
+        </p:spPr>
+        <p:style>
+          <a:lnRef idx="1">
+            <a:schemeClr val="accent1"/>
+          </a:lnRef>
+          <a:fillRef idx="3">
+            <a:schemeClr val="accent1"/>
+          </a:fillRef>
+          <a:effectRef idx="2">
+            <a:schemeClr val="accent1"/>
+          </a:effectRef>
+          <a:fontRef idx="minor">
+            <a:schemeClr val="lt1"/>
+          </a:fontRef>
+        </p:style>
+        <p:txBody>
+          <a:bodyPr rtlCol="0" anchor="ctr"/>
+          <a:lstStyle/>
+          <a:p>
+            <a:pPr algn="ctr"/>
+          </a:p>
+        </p:txBody>
+      </p:sp>
+      <p:sp>
+        <p:nvSpPr>
+          <p:cNvPr id="12" name="TextBox 11"/>
+          <p:cNvSpPr txBox="1"/>
+          <p:nvPr/>
+        </p:nvSpPr>
+        <p:spPr>
+          <a:xfrm>
+            <a:off x="621792" y="3630168"/>
+            <a:ext cx="3182112" cy="822960"/>
+          </a:xfrm>
+          <a:prstGeom prst="rect">
+            <a:avLst/>
+          </a:prstGeom>
+          <a:noFill/>
+        </p:spPr>
+        <p:txBody>
+          <a:bodyPr wrap="square">
+            <a:spAutoFit/>
+          </a:bodyPr>
+          <a:lstStyle/>
+          <a:p>
+            <a:pPr algn="l"/>
+            <a:r>
+              <a:rPr sz="1050" b="0" i="1">
+                <a:solidFill>
+                  <a:srgbClr val="1E3A6E"/>
+                </a:solidFill>
+              </a:rPr>
+              <a:t>"Compare this week's revenue vs. the same week last year."</a:t>
+            </a:r>
+          </a:p>
+        </p:txBody>
+      </p:sp>
+      <p:sp>
+        <p:nvSpPr>
+          <p:cNvPr id="13" name="Rectangle 12"/>
+          <p:cNvSpPr/>
+          <p:nvPr/>
+        </p:nvSpPr>
+        <p:spPr>
+          <a:xfrm>
+            <a:off x="530352" y="4590288"/>
+            <a:ext cx="3364992" cy="932688"/>
+          </a:xfrm>
+          <a:prstGeom prst="rect">
+            <a:avLst/>
+          </a:prstGeom>
+          <a:solidFill>
+            <a:srgbClr val="EBF3FF"/>
+          </a:solidFill>
+          <a:ln>
+            <a:noFill/>
+          </a:ln>
+        </p:spPr>
+        <p:style>
+          <a:lnRef idx="1">
+            <a:schemeClr val="accent1"/>
+          </a:lnRef>
+          <a:fillRef idx="3">
+            <a:schemeClr val="accent1"/>
+          </a:fillRef>
+          <a:effectRef idx="2">
+            <a:schemeClr val="accent1"/>
+          </a:effectRef>
+          <a:fontRef idx="minor">
+            <a:schemeClr val="lt1"/>
+          </a:fontRef>
+        </p:style>
+        <p:txBody>
+          <a:bodyPr rtlCol="0" anchor="ctr"/>
+          <a:lstStyle/>
+          <a:p>
+            <a:pPr algn="ctr"/>
+          </a:p>
+        </p:txBody>
+      </p:sp>
+      <p:sp>
+        <p:nvSpPr>
+          <p:cNvPr id="14" name="TextBox 13"/>
+          <p:cNvSpPr txBox="1"/>
+          <p:nvPr/>
+        </p:nvSpPr>
+        <p:spPr>
+          <a:xfrm>
+            <a:off x="621792" y="4681727"/>
+            <a:ext cx="3182112" cy="822960"/>
+          </a:xfrm>
+          <a:prstGeom prst="rect">
+            <a:avLst/>
+          </a:prstGeom>
+          <a:noFill/>
+        </p:spPr>
+        <p:txBody>
+          <a:bodyPr wrap="square">
+            <a:spAutoFit/>
+          </a:bodyPr>
+          <a:lstStyle/>
+          <a:p>
+            <a:pPr algn="l"/>
+            <a:r>
+              <a:rPr sz="1050" b="0" i="1">
+                <a:solidFill>
+                  <a:srgbClr val="1E3A6E"/>
+                </a:solidFill>
+              </a:rPr>
+              <a:t>"Which stores underperformed their sales targets in May?"</a:t>
+            </a:r>
+          </a:p>
+        </p:txBody>
+      </p:sp>
+      <p:sp>
+        <p:nvSpPr>
+          <p:cNvPr id="15" name="Rectangle 14"/>
+          <p:cNvSpPr/>
+          <p:nvPr/>
+        </p:nvSpPr>
+        <p:spPr>
+          <a:xfrm>
+            <a:off x="4247388" y="1298448"/>
+            <a:ext cx="3694176" cy="5349240"/>
+          </a:xfrm>
+          <a:prstGeom prst="rect">
+            <a:avLst/>
+          </a:prstGeom>
+          <a:solidFill>
+            <a:srgbClr val="F9FAFB"/>
+          </a:solidFill>
+          <a:ln>
+            <a:noFill/>
+          </a:ln>
+        </p:spPr>
+        <p:style>
+          <a:lnRef idx="1">
+            <a:schemeClr val="accent1"/>
+          </a:lnRef>
+          <a:fillRef idx="3">
+            <a:schemeClr val="accent1"/>
+          </a:fillRef>
+          <a:effectRef idx="2">
+            <a:schemeClr val="accent1"/>
+          </a:effectRef>
+          <a:fontRef idx="minor">
+            <a:schemeClr val="lt1"/>
+          </a:fontRef>
+        </p:style>
+        <p:txBody>
+          <a:bodyPr rtlCol="0" anchor="ctr"/>
+          <a:lstStyle/>
+          <a:p>
+            <a:pPr algn="ctr"/>
+          </a:p>
+        </p:txBody>
+      </p:sp>
+      <p:sp>
+        <p:nvSpPr>
+          <p:cNvPr id="16" name="Rectangle 15"/>
+          <p:cNvSpPr/>
+          <p:nvPr/>
+        </p:nvSpPr>
+        <p:spPr>
+          <a:xfrm>
+            <a:off x="4247388" y="1298448"/>
+            <a:ext cx="3694176" cy="91440"/>
+          </a:xfrm>
+          <a:prstGeom prst="rect">
+            <a:avLst/>
+          </a:prstGeom>
+          <a:solidFill>
+            <a:srgbClr val="7B3FF2"/>
+          </a:solidFill>
+          <a:ln>
+            <a:noFill/>
+          </a:ln>
+        </p:spPr>
+        <p:style>
+          <a:lnRef idx="1">
+            <a:schemeClr val="accent1"/>
+          </a:lnRef>
+          <a:fillRef idx="3">
+            <a:schemeClr val="accent1"/>
+          </a:fillRef>
+          <a:effectRef idx="2">
+            <a:schemeClr val="accent1"/>
+          </a:effectRef>
+          <a:fontRef idx="minor">
+            <a:schemeClr val="lt1"/>
+          </a:fontRef>
+        </p:style>
+        <p:txBody>
+          <a:bodyPr rtlCol="0" anchor="ctr"/>
+          <a:lstStyle/>
+          <a:p>
+            <a:pPr algn="ctr"/>
+          </a:p>
+        </p:txBody>
+      </p:sp>
+      <p:sp>
+        <p:nvSpPr>
+          <p:cNvPr id="17" name="TextBox 16"/>
+          <p:cNvSpPr txBox="1"/>
+          <p:nvPr/>
+        </p:nvSpPr>
+        <p:spPr>
+          <a:xfrm>
+            <a:off x="4411980" y="1453895"/>
+            <a:ext cx="3419856" cy="320040"/>
+          </a:xfrm>
+          <a:prstGeom prst="rect">
+            <a:avLst/>
+          </a:prstGeom>
+          <a:noFill/>
+        </p:spPr>
+        <p:txBody>
+          <a:bodyPr wrap="square">
+            <a:spAutoFit/>
+          </a:bodyPr>
+          <a:lstStyle/>
+          <a:p>
+            <a:pPr algn="l"/>
+            <a:r>
+              <a:rPr sz="950" b="1" i="0">
+                <a:solidFill>
+                  <a:srgbClr val="7B3FF2"/>
+                </a:solidFill>
+              </a:rPr>
+              <a:t>USE CASE 2</a:t>
+            </a:r>
+          </a:p>
+        </p:txBody>
+      </p:sp>
+      <p:sp>
+        <p:nvSpPr>
+          <p:cNvPr id="18" name="TextBox 17"/>
+          <p:cNvSpPr txBox="1"/>
+          <p:nvPr/>
+        </p:nvSpPr>
+        <p:spPr>
+          <a:xfrm>
+            <a:off x="4411980" y="1773936"/>
+            <a:ext cx="3419856" cy="566928"/>
+          </a:xfrm>
+          <a:prstGeom prst="rect">
+            <a:avLst/>
+          </a:prstGeom>
+          <a:noFill/>
+        </p:spPr>
+        <p:txBody>
+          <a:bodyPr wrap="square">
+            <a:spAutoFit/>
+          </a:bodyPr>
+          <a:lstStyle/>
+          <a:p>
+            <a:pPr algn="l"/>
+            <a:r>
+              <a:rPr sz="1700" b="1" i="0">
+                <a:solidFill>
+                  <a:srgbClr val="111827"/>
+                </a:solidFill>
+              </a:rPr>
+              <a:t>Product Intelligence</a:t>
+            </a:r>
+          </a:p>
+        </p:txBody>
+      </p:sp>
+      <p:sp>
+        <p:nvSpPr>
+          <p:cNvPr id="19" name="Rectangle 18"/>
+          <p:cNvSpPr/>
+          <p:nvPr/>
+        </p:nvSpPr>
+        <p:spPr>
+          <a:xfrm>
+            <a:off x="4411980" y="2377439"/>
+            <a:ext cx="3364992" cy="16459"/>
+          </a:xfrm>
+          <a:prstGeom prst="rect">
+            <a:avLst/>
+          </a:prstGeom>
+          <a:solidFill>
+            <a:srgbClr val="C4C9D4"/>
+          </a:solidFill>
+          <a:ln>
+            <a:noFill/>
+          </a:ln>
+        </p:spPr>
+        <p:style>
+          <a:lnRef idx="1">
+            <a:schemeClr val="accent1"/>
+          </a:lnRef>
+          <a:fillRef idx="3">
+            <a:schemeClr val="accent1"/>
+          </a:fillRef>
+          <a:effectRef idx="2">
+            <a:schemeClr val="accent1"/>
+          </a:effectRef>
+          <a:fontRef idx="minor">
+            <a:schemeClr val="lt1"/>
+          </a:fontRef>
+        </p:style>
+        <p:txBody>
+          <a:bodyPr rtlCol="0" anchor="ctr"/>
+          <a:lstStyle/>
+          <a:p>
+            <a:pPr algn="ctr"/>
+          </a:p>
+        </p:txBody>
+      </p:sp>
+      <p:sp>
+        <p:nvSpPr>
+          <p:cNvPr id="20" name="Rectangle 19"/>
+          <p:cNvSpPr/>
+          <p:nvPr/>
+        </p:nvSpPr>
+        <p:spPr>
+          <a:xfrm>
+            <a:off x="4411980" y="2487168"/>
+            <a:ext cx="3364992" cy="694944"/>
+          </a:xfrm>
+          <a:prstGeom prst="rect">
+            <a:avLst/>
+          </a:prstGeom>
+          <a:solidFill>
+            <a:srgbClr val="EBF3FF"/>
+          </a:solidFill>
+          <a:ln>
+            <a:noFill/>
+          </a:ln>
+        </p:spPr>
+        <p:style>
+          <a:lnRef idx="1">
+            <a:schemeClr val="accent1"/>
+          </a:lnRef>
+          <a:fillRef idx="3">
+            <a:schemeClr val="accent1"/>
+          </a:fillRef>
+          <a:effectRef idx="2">
+            <a:schemeClr val="accent1"/>
+          </a:effectRef>
+          <a:fontRef idx="minor">
+            <a:schemeClr val="lt1"/>
+          </a:fontRef>
+        </p:style>
+        <p:txBody>
+          <a:bodyPr rtlCol="0" anchor="ctr"/>
+          <a:lstStyle/>
+          <a:p>
+            <a:pPr algn="ctr"/>
+          </a:p>
+        </p:txBody>
+      </p:sp>
+      <p:sp>
+        <p:nvSpPr>
+          <p:cNvPr id="21" name="TextBox 20"/>
+          <p:cNvSpPr txBox="1"/>
+          <p:nvPr/>
+        </p:nvSpPr>
+        <p:spPr>
+          <a:xfrm>
+            <a:off x="4503420" y="2578608"/>
+            <a:ext cx="3182112" cy="585216"/>
+          </a:xfrm>
+          <a:prstGeom prst="rect">
+            <a:avLst/>
+          </a:prstGeom>
+          <a:noFill/>
+        </p:spPr>
+        <p:txBody>
+          <a:bodyPr wrap="square">
+            <a:spAutoFit/>
+          </a:bodyPr>
+          <a:lstStyle/>
+          <a:p>
+            <a:pPr algn="l"/>
+            <a:r>
+              <a:rPr sz="1050" b="0" i="1">
+                <a:solidFill>
+                  <a:srgbClr val="1E3A6E"/>
+                </a:solidFill>
+              </a:rPr>
+              <a:t>"What is driving Linen Drawstr to rank 1 this week?"</a:t>
+            </a:r>
+          </a:p>
+        </p:txBody>
+      </p:sp>
+      <p:sp>
+        <p:nvSpPr>
+          <p:cNvPr id="22" name="Rectangle 21"/>
+          <p:cNvSpPr/>
+          <p:nvPr/>
+        </p:nvSpPr>
+        <p:spPr>
+          <a:xfrm>
+            <a:off x="4411980" y="3300984"/>
+            <a:ext cx="3364992" cy="694944"/>
+          </a:xfrm>
+          <a:prstGeom prst="rect">
+            <a:avLst/>
+          </a:prstGeom>
+          <a:solidFill>
+            <a:srgbClr val="EBF3FF"/>
+          </a:solidFill>
+          <a:ln>
+            <a:noFill/>
+          </a:ln>
+        </p:spPr>
+        <p:style>
+          <a:lnRef idx="1">
+            <a:schemeClr val="accent1"/>
+          </a:lnRef>
+          <a:fillRef idx="3">
+            <a:schemeClr val="accent1"/>
+          </a:fillRef>
+          <a:effectRef idx="2">
+            <a:schemeClr val="accent1"/>
+          </a:effectRef>
+          <a:fontRef idx="minor">
+            <a:schemeClr val="lt1"/>
+          </a:fontRef>
+        </p:style>
+        <p:txBody>
+          <a:bodyPr rtlCol="0" anchor="ctr"/>
+          <a:lstStyle/>
+          <a:p>
+            <a:pPr algn="ctr"/>
+          </a:p>
+        </p:txBody>
+      </p:sp>
+      <p:sp>
+        <p:nvSpPr>
+          <p:cNvPr id="23" name="TextBox 22"/>
+          <p:cNvSpPr txBox="1"/>
+          <p:nvPr/>
+        </p:nvSpPr>
+        <p:spPr>
+          <a:xfrm>
+            <a:off x="4503420" y="3392424"/>
+            <a:ext cx="3182112" cy="585216"/>
+          </a:xfrm>
+          <a:prstGeom prst="rect">
+            <a:avLst/>
+          </a:prstGeom>
+          <a:noFill/>
+        </p:spPr>
+        <p:txBody>
+          <a:bodyPr wrap="square">
+            <a:spAutoFit/>
+          </a:bodyPr>
+          <a:lstStyle/>
+          <a:p>
+            <a:pPr algn="l"/>
+            <a:r>
+              <a:rPr sz="1050" b="0" i="1">
+                <a:solidFill>
+                  <a:srgbClr val="1E3A6E"/>
+                </a:solidFill>
+              </a:rPr>
+              <a:t>"SS HVY ORIGIN jumped 12 ranks — should I reorder?"</a:t>
+            </a:r>
+          </a:p>
+        </p:txBody>
+      </p:sp>
+      <p:sp>
+        <p:nvSpPr>
+          <p:cNvPr id="24" name="Rectangle 23"/>
+          <p:cNvSpPr/>
+          <p:nvPr/>
+        </p:nvSpPr>
+        <p:spPr>
+          <a:xfrm>
+            <a:off x="4411980" y="4114800"/>
+            <a:ext cx="3364992" cy="932688"/>
+          </a:xfrm>
+          <a:prstGeom prst="rect">
+            <a:avLst/>
+          </a:prstGeom>
+          <a:solidFill>
+            <a:srgbClr val="EBF3FF"/>
+          </a:solidFill>
+          <a:ln>
+            <a:noFill/>
+          </a:ln>
+        </p:spPr>
+        <p:style>
+          <a:lnRef idx="1">
+            <a:schemeClr val="accent1"/>
+          </a:lnRef>
+          <a:fillRef idx="3">
+            <a:schemeClr val="accent1"/>
+          </a:fillRef>
+          <a:effectRef idx="2">
+            <a:schemeClr val="accent1"/>
+          </a:effectRef>
+          <a:fontRef idx="minor">
+            <a:schemeClr val="lt1"/>
+          </a:fontRef>
+        </p:style>
+        <p:txBody>
+          <a:bodyPr rtlCol="0" anchor="ctr"/>
+          <a:lstStyle/>
+          <a:p>
+            <a:pPr algn="ctr"/>
+          </a:p>
+        </p:txBody>
+      </p:sp>
+      <p:sp>
+        <p:nvSpPr>
+          <p:cNvPr id="25" name="TextBox 24"/>
+          <p:cNvSpPr txBox="1"/>
+          <p:nvPr/>
+        </p:nvSpPr>
+        <p:spPr>
+          <a:xfrm>
+            <a:off x="4503420" y="4206240"/>
+            <a:ext cx="3182112" cy="822960"/>
+          </a:xfrm>
+          <a:prstGeom prst="rect">
+            <a:avLst/>
+          </a:prstGeom>
+          <a:noFill/>
+        </p:spPr>
+        <p:txBody>
+          <a:bodyPr wrap="square">
+            <a:spAutoFit/>
+          </a:bodyPr>
+          <a:lstStyle/>
+          <a:p>
+            <a:pPr algn="l"/>
+            <a:r>
+              <a:rPr sz="1050" b="0" i="1">
+                <a:solidFill>
+                  <a:srgbClr val="1E3A6E"/>
+                </a:solidFill>
+              </a:rPr>
+              <a:t>"Show me the top product in each category this week."</a:t>
+            </a:r>
+          </a:p>
+        </p:txBody>
+      </p:sp>
+      <p:sp>
+        <p:nvSpPr>
+          <p:cNvPr id="26" name="Rectangle 25"/>
+          <p:cNvSpPr/>
+          <p:nvPr/>
+        </p:nvSpPr>
+        <p:spPr>
+          <a:xfrm>
+            <a:off x="8129016" y="1298448"/>
+            <a:ext cx="3694176" cy="5349240"/>
+          </a:xfrm>
+          <a:prstGeom prst="rect">
+            <a:avLst/>
+          </a:prstGeom>
+          <a:solidFill>
+            <a:srgbClr val="F9FAFB"/>
+          </a:solidFill>
+          <a:ln>
+            <a:noFill/>
+          </a:ln>
+        </p:spPr>
+        <p:style>
+          <a:lnRef idx="1">
+            <a:schemeClr val="accent1"/>
+          </a:lnRef>
+          <a:fillRef idx="3">
+            <a:schemeClr val="accent1"/>
+          </a:fillRef>
+          <a:effectRef idx="2">
+            <a:schemeClr val="accent1"/>
+          </a:effectRef>
+          <a:fontRef idx="minor">
+            <a:schemeClr val="lt1"/>
+          </a:fontRef>
+        </p:style>
+        <p:txBody>
+          <a:bodyPr rtlCol="0" anchor="ctr"/>
+          <a:lstStyle/>
+          <a:p>
+            <a:pPr algn="ctr"/>
+          </a:p>
+        </p:txBody>
+      </p:sp>
+      <p:sp>
+        <p:nvSpPr>
+          <p:cNvPr id="27" name="Rectangle 26"/>
+          <p:cNvSpPr/>
+          <p:nvPr/>
+        </p:nvSpPr>
+        <p:spPr>
+          <a:xfrm>
+            <a:off x="8129016" y="1298448"/>
+            <a:ext cx="3694176" cy="91440"/>
+          </a:xfrm>
+          <a:prstGeom prst="rect">
+            <a:avLst/>
+          </a:prstGeom>
+          <a:solidFill>
+            <a:srgbClr val="EA580C"/>
+          </a:solidFill>
+          <a:ln>
+            <a:noFill/>
+          </a:ln>
+        </p:spPr>
+        <p:style>
+          <a:lnRef idx="1">
+            <a:schemeClr val="accent1"/>
+          </a:lnRef>
+          <a:fillRef idx="3">
+            <a:schemeClr val="accent1"/>
+          </a:fillRef>
+          <a:effectRef idx="2">
+            <a:schemeClr val="accent1"/>
+          </a:effectRef>
+          <a:fontRef idx="minor">
+            <a:schemeClr val="lt1"/>
+          </a:fontRef>
+        </p:style>
+        <p:txBody>
+          <a:bodyPr rtlCol="0" anchor="ctr"/>
+          <a:lstStyle/>
+          <a:p>
+            <a:pPr algn="ctr"/>
+          </a:p>
+        </p:txBody>
+      </p:sp>
+      <p:sp>
+        <p:nvSpPr>
+          <p:cNvPr id="28" name="TextBox 27"/>
+          <p:cNvSpPr txBox="1"/>
+          <p:nvPr/>
+        </p:nvSpPr>
+        <p:spPr>
+          <a:xfrm>
+            <a:off x="8293608" y="1453895"/>
+            <a:ext cx="3419856" cy="320040"/>
+          </a:xfrm>
+          <a:prstGeom prst="rect">
+            <a:avLst/>
+          </a:prstGeom>
+          <a:noFill/>
+        </p:spPr>
+        <p:txBody>
+          <a:bodyPr wrap="square">
+            <a:spAutoFit/>
+          </a:bodyPr>
+          <a:lstStyle/>
+          <a:p>
+            <a:pPr algn="l"/>
+            <a:r>
+              <a:rPr sz="950" b="1" i="0">
+                <a:solidFill>
+                  <a:srgbClr val="EA580C"/>
+                </a:solidFill>
+              </a:rPr>
+              <a:t>USE CASE 3</a:t>
+            </a:r>
+          </a:p>
+        </p:txBody>
+      </p:sp>
+      <p:sp>
+        <p:nvSpPr>
+          <p:cNvPr id="29" name="TextBox 28"/>
+          <p:cNvSpPr txBox="1"/>
+          <p:nvPr/>
+        </p:nvSpPr>
+        <p:spPr>
+          <a:xfrm>
+            <a:off x="8293608" y="1773936"/>
+            <a:ext cx="3419856" cy="566928"/>
+          </a:xfrm>
+          <a:prstGeom prst="rect">
+            <a:avLst/>
+          </a:prstGeom>
+          <a:noFill/>
+        </p:spPr>
+        <p:txBody>
+          <a:bodyPr wrap="square">
+            <a:spAutoFit/>
+          </a:bodyPr>
+          <a:lstStyle/>
+          <a:p>
+            <a:pPr algn="l"/>
+            <a:r>
+              <a:rPr sz="1700" b="1" i="0">
+                <a:solidFill>
+                  <a:srgbClr val="111827"/>
+                </a:solidFill>
+              </a:rPr>
+              <a:t>Location &amp; Store</a:t>
+            </a:r>
+          </a:p>
+        </p:txBody>
+      </p:sp>
+      <p:sp>
+        <p:nvSpPr>
+          <p:cNvPr id="30" name="Rectangle 29"/>
+          <p:cNvSpPr/>
+          <p:nvPr/>
+        </p:nvSpPr>
+        <p:spPr>
+          <a:xfrm>
+            <a:off x="8293608" y="2377439"/>
+            <a:ext cx="3364992" cy="16459"/>
+          </a:xfrm>
+          <a:prstGeom prst="rect">
+            <a:avLst/>
+          </a:prstGeom>
+          <a:solidFill>
+            <a:srgbClr val="C4C9D4"/>
+          </a:solidFill>
+          <a:ln>
+            <a:noFill/>
+          </a:ln>
+        </p:spPr>
+        <p:style>
+          <a:lnRef idx="1">
+            <a:schemeClr val="accent1"/>
+          </a:lnRef>
+          <a:fillRef idx="3">
+            <a:schemeClr val="accent1"/>
+          </a:fillRef>
+          <a:effectRef idx="2">
+            <a:schemeClr val="accent1"/>
+          </a:effectRef>
+          <a:fontRef idx="minor">
+            <a:schemeClr val="lt1"/>
+          </a:fontRef>
+        </p:style>
+        <p:txBody>
+          <a:bodyPr rtlCol="0" anchor="ctr"/>
+          <a:lstStyle/>
+          <a:p>
+            <a:pPr algn="ctr"/>
+          </a:p>
+        </p:txBody>
+      </p:sp>
+      <p:sp>
+        <p:nvSpPr>
+          <p:cNvPr id="31" name="Rectangle 30"/>
+          <p:cNvSpPr/>
+          <p:nvPr/>
+        </p:nvSpPr>
+        <p:spPr>
+          <a:xfrm>
+            <a:off x="8293608" y="2487168"/>
+            <a:ext cx="3364992" cy="932688"/>
+          </a:xfrm>
+          <a:prstGeom prst="rect">
+            <a:avLst/>
+          </a:prstGeom>
+          <a:solidFill>
+            <a:srgbClr val="EBF3FF"/>
+          </a:solidFill>
+          <a:ln>
+            <a:noFill/>
+          </a:ln>
+        </p:spPr>
+        <p:style>
+          <a:lnRef idx="1">
+            <a:schemeClr val="accent1"/>
+          </a:lnRef>
+          <a:fillRef idx="3">
+            <a:schemeClr val="accent1"/>
+          </a:fillRef>
+          <a:effectRef idx="2">
+            <a:schemeClr val="accent1"/>
+          </a:effectRef>
+          <a:fontRef idx="minor">
+            <a:schemeClr val="lt1"/>
+          </a:fontRef>
+        </p:style>
+        <p:txBody>
+          <a:bodyPr rtlCol="0" anchor="ctr"/>
+          <a:lstStyle/>
+          <a:p>
+            <a:pPr algn="ctr"/>
+          </a:p>
+        </p:txBody>
+      </p:sp>
+      <p:sp>
+        <p:nvSpPr>
+          <p:cNvPr id="32" name="TextBox 31"/>
+          <p:cNvSpPr txBox="1"/>
+          <p:nvPr/>
+        </p:nvSpPr>
+        <p:spPr>
+          <a:xfrm>
+            <a:off x="8385048" y="2578608"/>
+            <a:ext cx="3182112" cy="822960"/>
+          </a:xfrm>
+          <a:prstGeom prst="rect">
+            <a:avLst/>
+          </a:prstGeom>
+          <a:noFill/>
+        </p:spPr>
+        <p:txBody>
+          <a:bodyPr wrap="square">
+            <a:spAutoFit/>
+          </a:bodyPr>
+          <a:lstStyle/>
+          <a:p>
+            <a:pPr algn="l"/>
+            <a:r>
+              <a:rPr sz="1050" b="0" i="1">
+                <a:solidFill>
+                  <a:srgbClr val="1E3A6E"/>
+                </a:solidFill>
+              </a:rPr>
+              <a:t>"Show me the top 5 stores in GAP Northeast by sales this week."</a:t>
             </a:r>
           </a:p>
         </p:txBody>

</xml_diff>